<commit_message>
同步 PPTX/HTML 用語、修正藍圖遺漏、移除 cilt-website submodule
</commit_message>
<xml_diff>
--- a/AI_Agent_技術架構藍圖.pptx
+++ b/AI_Agent_技術架構藍圖.pptx
@@ -3169,7 +3169,7 @@
             </a:r>
             <a:r>
               <a:rPr dirty="0"/>
-              <a:t>  |  </a:t>
+              <a:t xml:space="preserve">  |  </a:t>
             </a:r>
             <a:r>
               <a:rPr dirty="0" err="1"/>
@@ -3177,7 +3177,7 @@
             </a:r>
             <a:r>
               <a:rPr dirty="0"/>
-              <a:t> × MVP </a:t>
+              <a:t xml:space="preserve"> × MVP </a:t>
             </a:r>
             <a:r>
               <a:rPr dirty="0" err="1"/>
@@ -3185,7 +3185,7 @@
             </a:r>
             <a:r>
               <a:rPr dirty="0"/>
-              <a:t> × 12 </a:t>
+              <a:t xml:space="preserve"> × 12 </a:t>
             </a:r>
             <a:r>
               <a:rPr dirty="0" err="1"/>
@@ -3474,7 +3474,7 @@
             </a:r>
             <a:br/>
             <a:r>
-              <a:t>支援排程任務、多代理協作、13,700+ 技能插件生態系。</a:t>
+              <a:t>支援排程任務、多 Agent 協作、13,700+ 技能插件生態系。</a:t>
             </a:r>
           </a:p>
         </p:txBody>
@@ -4998,7 +4998,7 @@
                 </a:solidFill>
                 <a:latin typeface="Microsoft JhengHei"/>
               </a:rPr>
-              <a:t>M0 </a:t>
+              <a:t xml:space="preserve">M0 </a:t>
             </a:r>
             <a:r>
               <a:rPr sz="900" b="1" dirty="0" err="1">
@@ -5477,7 +5477,7 @@
             </a:pPr>
             <a:r>
               <a:rPr lang="en-US" dirty="0"/>
-              <a:t>A </a:t>
+              <a:t xml:space="preserve">A </a:t>
             </a:r>
             <a:r>
               <a:rPr dirty="0" err="1"/>
@@ -5485,7 +5485,7 @@
             </a:r>
             <a:r>
               <a:rPr dirty="0"/>
-              <a:t> </a:t>
+              <a:t xml:space="preserve"> </a:t>
             </a:r>
             <a:r>
               <a:rPr dirty="0" err="1"/>
@@ -5504,7 +5504,7 @@
             </a:r>
             <a:r>
               <a:rPr dirty="0"/>
-              <a:t> </a:t>
+              <a:t xml:space="preserve"> </a:t>
             </a:r>
             <a:r>
               <a:rPr dirty="0" err="1"/>
@@ -5519,7 +5519,7 @@
             </a:r>
             <a:r>
               <a:rPr dirty="0"/>
-              <a:t> </a:t>
+              <a:t xml:space="preserve"> </a:t>
             </a:r>
             <a:r>
               <a:rPr dirty="0" err="1"/>
@@ -5527,7 +5527,7 @@
             </a:r>
             <a:r>
               <a:rPr dirty="0"/>
-              <a:t> 1 </a:t>
+              <a:t xml:space="preserve"> 1 </a:t>
             </a:r>
             <a:r>
               <a:rPr dirty="0" err="1"/>
@@ -5535,7 +5535,7 @@
             </a:r>
             <a:r>
               <a:rPr dirty="0"/>
-              <a:t> AI Agent POC</a:t>
+              <a:t xml:space="preserve"> AI Agent POC</a:t>
             </a:r>
           </a:p>
         </p:txBody>
@@ -6176,7 +6176,7 @@
             </a:r>
             <a:br/>
             <a:r>
-              <a:t>• 多代理協作與自動化流程</a:t>
+              <a:t>• 多 Agent 協作與自動化流程</a:t>
             </a:r>
             <a:br/>
             <a:r>

</xml_diff>